<commit_message>
Version initiale du deck FX3_slides
</commit_message>
<xml_diff>
--- a/_slides/remanies/14. FX2_slides.pptx
+++ b/_slides/remanies/14. FX2_slides.pptx
@@ -892,6 +892,12 @@
               <a:t> défait le lien quand il le faut.</a:t>
             </a:r>
           </a:p>
+          <a:p>
+            <a:r>
+              <a:rPr lang="fr-BE" dirty="0"/>
+              <a:t>Le code complet, à lancer : demos, classe demo.fx.slides.fx2.LanceurVariateur.</a:t>
+            </a:r>
+          </a:p>
         </p:txBody>
       </p:sp>
       <p:sp>
@@ -1130,6 +1136,12 @@
               <a:t>Les deux propriétés doivent être du même genre : deux nombres, deux textes, deux booléens.</a:t>
             </a:r>
           </a:p>
+          <a:p>
+            <a:r>
+              <a:rPr lang="fr-BE" dirty="0"/>
+              <a:t>Le code complet, à lancer : demos, classe demo.fx.slides.fx2.LanceurVariateur.</a:t>
+            </a:r>
+          </a:p>
         </p:txBody>
       </p:sp>
       <p:sp>
@@ -1472,6 +1484,12 @@
               <a:t>Remarquez aussi que le modèle ne contient pas de propriété JavaFX. Ce serait tentant, pour le lier directement à la vue ; ce serait aussi importer JavaFX dans le modèle. Le modèle de FX.9 n'en contient pas.</a:t>
             </a:r>
           </a:p>
+          <a:p>
+            <a:r>
+              <a:rPr lang="fr-BE" dirty="0"/>
+              <a:t>Le code complet : demos, classe demo.fx.slides.fx2.Lampe.</a:t>
+            </a:r>
+          </a:p>
         </p:txBody>
       </p:sp>
       <p:sp>
@@ -1607,35 +1625,20 @@
           <a:lstStyle/>
           <a:p>
             <a:r>
-              <a:t>Une vue construite en Java mélange deux choses : la structure de l'écran, quels conteneurs, quels contrôles, et la façon de la construire, les </a:t>
-            </a:r>
-            <a:r>
-              <a:rPr>
-                <a:latin typeface="Consolas"/>
-              </a:rPr>
-              <a:t>new</a:t>
-            </a:r>
-            <a:r>
-              <a:t> et les </a:t>
-            </a:r>
-            <a:r>
-              <a:rPr>
-                <a:latin typeface="Consolas"/>
-              </a:rPr>
-              <a:t>getChildren</a:t>
-            </a:r>
-            <a:r>
-              <a:t>. Le FXML ne garde que la structure, dans un fichier XML que JavaFX transforme en objets au chargement.</a:t>
-            </a:r>
-          </a:p>
-          <a:p>
-            <a:r>
+              <a:rPr lang="fr-BE" dirty="0"/>
+              <a:t>Une vue construite en Java mélange deux choses : la structure de l'écran, quels conteneurs, quels contrôles, et la façon de la construire, les new et les getChildren. Le FXML ne garde que la structure, dans un fichier XML que JavaFX transforme en objets au chargement.</a:t>
+            </a:r>
+          </a:p>
+          <a:p>
+            <a:r>
+              <a:rPr lang="fr-BE" dirty="0"/>
               <a:t>On y gagne une séparation de plus : le fichier décrit ce qu'on voit, le contrôleur ce qui se passe. On peut aussi le modifier sans recompiler, et le dessiner avec Scene Builder, un éditeur visuel facultatif. Son installation est décrite en IDE.29 du guide IntelliJ.</a:t>
             </a:r>
           </a:p>
           <a:p>
             <a:r>
-              <a:t>Le FXML n'est pas au programme de l'examen : la question JavaFX se résout toujours en Java. Il vous sert à comprendre comment se construisent les vraies applications, et à faire FX.9, dont la vue vous est fournie.</a:t>
+              <a:rPr lang="fr-BE" dirty="0"/>
+              <a:t>Le FXML n'est pas au programme de l'examen : la question JavaFX se résout toujours en Java. Il vous sert à comprendre comment se construisent les vraies applications, et à faire FX.9, où vous l'écrirez vous-même, guidé pas à pas par le deck FX3.</a:t>
             </a:r>
           </a:p>
         </p:txBody>
@@ -1781,6 +1784,12 @@
               <a:t> correspond à un attribut.</a:t>
             </a:r>
           </a:p>
+          <a:p>
+            <a:r>
+              <a:rPr lang="fr-BE" dirty="0"/>
+              <a:t>Le code complet, à lancer : demos, classe demo.fx.slides.fx2.LanceurApplicationLampe.</a:t>
+            </a:r>
+          </a:p>
         </p:txBody>
       </p:sp>
       <p:sp>
@@ -1999,6 +2008,12 @@
               <a:t> de FX.9, qui vous est fournie. Elle ne crée aucun composant et ne branche aucun gestionnaire : tout est dans le fichier et dans le contrôleur.</a:t>
             </a:r>
           </a:p>
+          <a:p>
+            <a:r>
+              <a:rPr lang="fr-BE" dirty="0"/>
+              <a:t>Le code complet, à lancer : demos, classe demo.fx.slides.fx2.LanceurApplicationLampe.</a:t>
+            </a:r>
+          </a:p>
         </p:txBody>
       </p:sp>
       <p:sp>
@@ -2171,6 +2186,12 @@
               <a:t> reste disponible. C'est ce qui permettra à FX.9 de brancher dix boutons sur une seule méthode.</a:t>
             </a:r>
           </a:p>
+          <a:p>
+            <a:r>
+              <a:rPr lang="fr-BE" dirty="0"/>
+              <a:t>Le code complet, à lancer : demos, classe demo.fx.slides.fx2.LanceurApplicationLampe.</a:t>
+            </a:r>
+          </a:p>
         </p:txBody>
       </p:sp>
       <p:sp>
@@ -2238,23 +2259,14 @@
           <a:lstStyle/>
           <a:p>
             <a:r>
-              <a:rPr>
-                <a:latin typeface="Consolas"/>
-              </a:rPr>
-              <a:t>FX.9</a:t>
-            </a:r>
-            <a:r>
-              <a:t> est la seule application complète du thème. La vue et la classe d'application sont fournies ; vous écrivez le modèle, puis le contrôleur.</a:t>
-            </a:r>
-          </a:p>
-          <a:p>
-            <a:r>
-              <a:t>Commencez par le modèle, et vérifiez-le avant de toucher au contrôleur : la première question de fin vous demande d'écrire sa classe de test, et c'est le bon moment. Un contrôleur qui appelle un modèle juste est bien plus simple à mettre au point.</a:t>
-            </a:r>
-          </a:p>
-          <a:p>
-            <a:r>
-              <a:t>Lisez le fichier FXML avant d'écrire le contrôleur. Il vous dit les noms de champs et de méthodes que le contrôleur doit porter.</a:t>
+              <a:rPr lang="fr-BE" dirty="0"/>
+              <a:t>FX.9 est la seule application complète du thème, et le deck FX3, « La calculatrice, pas à pas », la construit avec vous : la vue en FXML d'abord, puis le contrôleur branché sur ses boutons, enfin le modèle et les opérateurs. La classe d'application et le Lanceur sont fournis.</a:t>
+            </a:r>
+          </a:p>
+          <a:p>
+            <a:r>
+              <a:rPr lang="fr-BE" dirty="0"/>
+              <a:t>Suivez le deck dans l'ordre, et faites chaque étape dans votre projet au moment où elle est montrée. Quand vient le modèle, vérifiez-le avant d'écrire les opérateurs : la première question de fin vous demande d'écrire sa classe de test, et c'est le bon moment. Un contrôleur qui appelle un modèle juste est bien plus simple à mettre au point.</a:t>
             </a:r>
           </a:p>
         </p:txBody>
@@ -2729,6 +2741,12 @@
               <a:t> : la propriété ne change jamais, c'est sa valeur qui change. Les contrôles JavaFX sont tous écrits sur ce modèle, et c'est ce qui vous permettra de reconnaître leurs propriétés dans la Javadoc.</a:t>
             </a:r>
           </a:p>
+          <a:p>
+            <a:r>
+              <a:rPr lang="fr-BE" dirty="0"/>
+              <a:t>Le code complet, à lancer : demos, classe demo.fx.slides.fx2.ProprietesEnConsole.</a:t>
+            </a:r>
+          </a:p>
         </p:txBody>
       </p:sp>
       <p:sp>
@@ -2901,6 +2919,12 @@
               <a:t>Retenez surtout la dernière puce. Un listener ne dit rien tant que rien ne change : pour afficher la valeur de départ, il faut l'afficher soi-même.</a:t>
             </a:r>
           </a:p>
+          <a:p>
+            <a:r>
+              <a:rPr lang="fr-BE" dirty="0"/>
+              <a:t>Le code complet, à lancer : demos, classe demo.fx.slides.fx2.ProprietesEnConsole.</a:t>
+            </a:r>
+          </a:p>
         </p:txBody>
       </p:sp>
       <p:sp>
@@ -3015,6 +3039,12 @@
             </a:r>
             <a:r>
               <a:t>. Ctrl+Q ouvre la Javadoc sans quitter l'éditeur, voir IDE.14. C'est la démarche de FX.6.</a:t>
+            </a:r>
+          </a:p>
+          <a:p>
+            <a:r>
+              <a:rPr lang="fr-BE" dirty="0"/>
+              <a:t>Le code complet, à lancer : demos, classe demo.fx.slides.fx2.LanceurVariateur.</a:t>
             </a:r>
           </a:p>
         </p:txBody>
@@ -11411,8 +11441,8 @@
         </p:nvSpPr>
         <p:spPr>
           <a:xfrm>
-            <a:off x="1853494" y="3307080"/>
-            <a:ext cx="8485011" cy="2865120"/>
+            <a:off x="1853494" y="4792716"/>
+            <a:ext cx="8485011" cy="1379483"/>
           </a:xfrm>
           <a:prstGeom prst="roundRect">
             <a:avLst>
@@ -11446,16 +11476,16 @@
               </a:spcAft>
             </a:pPr>
             <a:r>
-              <a:rPr sz="1700">
+              <a:rPr sz="1700" dirty="0">
                 <a:solidFill>
                   <a:srgbClr val="CF8E6D"/>
                 </a:solidFill>
                 <a:latin typeface="Consolas"/>
               </a:rPr>
-              <a:t>public</a:t>
-            </a:r>
-            <a:r>
-              <a:rPr sz="1700">
+              <a:t>private</a:t>
+            </a:r>
+            <a:r>
+              <a:rPr sz="1700" dirty="0">
                 <a:solidFill>
                   <a:srgbClr val="BCBEC4"/>
                 </a:solidFill>
@@ -11464,32 +11494,65 @@
               <a:t> </a:t>
             </a:r>
             <a:r>
-              <a:rPr sz="1700">
+              <a:rPr sz="1700" dirty="0">
                 <a:solidFill>
                   <a:srgbClr val="CF8E6D"/>
                 </a:solidFill>
                 <a:latin typeface="Consolas"/>
               </a:rPr>
-              <a:t>class</a:t>
-            </a:r>
-            <a:r>
-              <a:rPr sz="1700">
+              <a:t>void</a:t>
+            </a:r>
+            <a:r>
+              <a:rPr sz="1700" dirty="0">
                 <a:solidFill>
                   <a:srgbClr val="BCBEC4"/>
                 </a:solidFill>
                 <a:latin typeface="Consolas"/>
               </a:rPr>
-              <a:t> Lampe {                 </a:t>
-            </a:r>
-            <a:r>
-              <a:rPr sz="1700">
+              <a:t> </a:t>
+            </a:r>
+            <a:r>
+              <a:rPr sz="1700" dirty="0" err="1">
+                <a:solidFill>
+                  <a:srgbClr val="56A8F5"/>
+                </a:solidFill>
+                <a:latin typeface="Consolas"/>
+              </a:rPr>
+              <a:t>basculer</a:t>
+            </a:r>
+            <a:r>
+              <a:rPr sz="1700" dirty="0">
+                <a:solidFill>
+                  <a:srgbClr val="BCBEC4"/>
+                </a:solidFill>
+                <a:latin typeface="Consolas"/>
+              </a:rPr>
+              <a:t>() {            </a:t>
+            </a:r>
+            <a:r>
+              <a:rPr sz="1700" dirty="0">
                 <a:solidFill>
                   <a:srgbClr val="7A7E85"/>
                 </a:solidFill>
                 <a:latin typeface="Consolas"/>
               </a:rPr>
-              <a:t>// le modele, sans JavaFX</a:t>
-            </a:r>
+              <a:t>// dans le </a:t>
+            </a:r>
+            <a:r>
+              <a:rPr sz="1700" dirty="0" err="1">
+                <a:solidFill>
+                  <a:srgbClr val="7A7E85"/>
+                </a:solidFill>
+                <a:latin typeface="Consolas"/>
+              </a:rPr>
+              <a:t>controleur</a:t>
+            </a:r>
+            <a:endParaRPr sz="1700" dirty="0">
+              <a:solidFill>
+                <a:srgbClr val="7A7E85"/>
+              </a:solidFill>
+              <a:latin typeface="Consolas"/>
+            </a:endParaRPr>
           </a:p>
           <a:p>
             <a:pPr>
@@ -11504,7 +11567,7 @@
               </a:spcAft>
             </a:pPr>
             <a:r>
-              <a:rPr sz="1700">
+              <a:rPr sz="1700" dirty="0">
                 <a:solidFill>
                   <a:srgbClr val="BCBEC4"/>
                 </a:solidFill>
@@ -11513,40 +11576,31 @@
               <a:t>    </a:t>
             </a:r>
             <a:r>
-              <a:rPr sz="1700">
-                <a:solidFill>
-                  <a:srgbClr val="CF8E6D"/>
-                </a:solidFill>
-                <a:latin typeface="Consolas"/>
-              </a:rPr>
-              <a:t>private</a:t>
-            </a:r>
-            <a:r>
-              <a:rPr sz="1700">
+              <a:rPr sz="1700" dirty="0" err="1">
                 <a:solidFill>
                   <a:srgbClr val="BCBEC4"/>
                 </a:solidFill>
                 <a:latin typeface="Consolas"/>
               </a:rPr>
-              <a:t> </a:t>
-            </a:r>
-            <a:r>
-              <a:rPr sz="1700">
-                <a:solidFill>
-                  <a:srgbClr val="CF8E6D"/>
-                </a:solidFill>
-                <a:latin typeface="Consolas"/>
-              </a:rPr>
-              <a:t>boolean</a:t>
-            </a:r>
-            <a:r>
-              <a:rPr sz="1700">
+              <a:t>lampe.</a:t>
+            </a:r>
+            <a:r>
+              <a:rPr sz="1700" dirty="0" err="1">
+                <a:solidFill>
+                  <a:srgbClr val="56A8F5"/>
+                </a:solidFill>
+                <a:latin typeface="Consolas"/>
+              </a:rPr>
+              <a:t>basculer</a:t>
+            </a:r>
+            <a:r>
+              <a:rPr sz="1700" dirty="0">
                 <a:solidFill>
                   <a:srgbClr val="BCBEC4"/>
                 </a:solidFill>
                 <a:latin typeface="Consolas"/>
               </a:rPr>
-              <a:t> allumee;</a:t>
+              <a:t>();</a:t>
             </a:r>
           </a:p>
           <a:p>
@@ -11562,7 +11616,7 @@
               </a:spcAft>
             </a:pPr>
             <a:r>
-              <a:rPr sz="1700">
+              <a:rPr sz="1700" dirty="0">
                 <a:solidFill>
                   <a:srgbClr val="BCBEC4"/>
                 </a:solidFill>
@@ -11571,58 +11625,130 @@
               <a:t>    </a:t>
             </a:r>
             <a:r>
-              <a:rPr sz="1700">
-                <a:solidFill>
-                  <a:srgbClr val="CF8E6D"/>
-                </a:solidFill>
-                <a:latin typeface="Consolas"/>
-              </a:rPr>
-              <a:t>public</a:t>
-            </a:r>
-            <a:r>
-              <a:rPr sz="1700">
+              <a:rPr sz="1700" dirty="0" err="1">
                 <a:solidFill>
                   <a:srgbClr val="BCBEC4"/>
                 </a:solidFill>
                 <a:latin typeface="Consolas"/>
               </a:rPr>
-              <a:t> </a:t>
-            </a:r>
-            <a:r>
-              <a:rPr sz="1700">
-                <a:solidFill>
-                  <a:srgbClr val="CF8E6D"/>
-                </a:solidFill>
-                <a:latin typeface="Consolas"/>
-              </a:rPr>
-              <a:t>void</a:t>
-            </a:r>
-            <a:r>
-              <a:rPr sz="1700">
+              <a:t>etat.</a:t>
+            </a:r>
+            <a:r>
+              <a:rPr sz="1700" dirty="0" err="1">
+                <a:solidFill>
+                  <a:srgbClr val="56A8F5"/>
+                </a:solidFill>
+                <a:latin typeface="Consolas"/>
+              </a:rPr>
+              <a:t>setText</a:t>
+            </a:r>
+            <a:r>
+              <a:rPr sz="1700" dirty="0">
                 <a:solidFill>
                   <a:srgbClr val="BCBEC4"/>
                 </a:solidFill>
                 <a:latin typeface="Consolas"/>
               </a:rPr>
-              <a:t> </a:t>
-            </a:r>
-            <a:r>
-              <a:rPr sz="1700">
+              <a:t>(</a:t>
+            </a:r>
+            <a:r>
+              <a:rPr sz="1700" dirty="0" err="1">
+                <a:solidFill>
+                  <a:srgbClr val="BCBEC4"/>
+                </a:solidFill>
+                <a:latin typeface="Consolas"/>
+              </a:rPr>
+              <a:t>lampe.</a:t>
+            </a:r>
+            <a:r>
+              <a:rPr sz="1700" dirty="0" err="1">
                 <a:solidFill>
                   <a:srgbClr val="56A8F5"/>
                 </a:solidFill>
                 <a:latin typeface="Consolas"/>
               </a:rPr>
-              <a:t>basculer</a:t>
-            </a:r>
-            <a:r>
-              <a:rPr sz="1700">
+              <a:t>estAllumee</a:t>
+            </a:r>
+            <a:r>
+              <a:rPr sz="1700" dirty="0">
                 <a:solidFill>
                   <a:srgbClr val="BCBEC4"/>
                 </a:solidFill>
                 <a:latin typeface="Consolas"/>
               </a:rPr>
-              <a:t>() { allumee = !allumee; }</a:t>
+              <a:t>() ? </a:t>
+            </a:r>
+            <a:r>
+              <a:rPr sz="1700" dirty="0">
+                <a:solidFill>
+                  <a:srgbClr val="6AAB73"/>
+                </a:solidFill>
+                <a:latin typeface="Consolas"/>
+              </a:rPr>
+              <a:t>"</a:t>
+            </a:r>
+            <a:r>
+              <a:rPr sz="1700" dirty="0" err="1">
+                <a:solidFill>
+                  <a:srgbClr val="6AAB73"/>
+                </a:solidFill>
+                <a:latin typeface="Consolas"/>
+              </a:rPr>
+              <a:t>Allumee</a:t>
+            </a:r>
+            <a:r>
+              <a:rPr sz="1700" dirty="0">
+                <a:solidFill>
+                  <a:srgbClr val="6AAB73"/>
+                </a:solidFill>
+                <a:latin typeface="Consolas"/>
+              </a:rPr>
+              <a:t>"</a:t>
+            </a:r>
+            <a:r>
+              <a:rPr sz="1700" dirty="0">
+                <a:solidFill>
+                  <a:srgbClr val="BCBEC4"/>
+                </a:solidFill>
+                <a:latin typeface="Consolas"/>
+              </a:rPr>
+              <a:t> : </a:t>
+            </a:r>
+            <a:r>
+              <a:rPr sz="1700" dirty="0">
+                <a:solidFill>
+                  <a:srgbClr val="6AAB73"/>
+                </a:solidFill>
+                <a:latin typeface="Consolas"/>
+              </a:rPr>
+              <a:t>"</a:t>
+            </a:r>
+            <a:r>
+              <a:rPr sz="1700" dirty="0" err="1">
+                <a:solidFill>
+                  <a:srgbClr val="6AAB73"/>
+                </a:solidFill>
+                <a:latin typeface="Consolas"/>
+              </a:rPr>
+              <a:t>Eteinte</a:t>
+            </a:r>
+            <a:r>
+              <a:rPr sz="1700" dirty="0">
+                <a:solidFill>
+                  <a:srgbClr val="6AAB73"/>
+                </a:solidFill>
+                <a:latin typeface="Consolas"/>
+              </a:rPr>
+              <a:t>"</a:t>
+            </a:r>
+            <a:r>
+              <a:rPr sz="1700" dirty="0">
+                <a:solidFill>
+                  <a:srgbClr val="BCBEC4"/>
+                </a:solidFill>
+                <a:latin typeface="Consolas"/>
+              </a:rPr>
+              <a:t>);</a:t>
             </a:r>
           </a:p>
           <a:p>
@@ -11638,355 +11764,7 @@
               </a:spcAft>
             </a:pPr>
             <a:r>
-              <a:rPr sz="1700">
-                <a:solidFill>
-                  <a:srgbClr val="BCBEC4"/>
-                </a:solidFill>
-                <a:latin typeface="Consolas"/>
-              </a:rPr>
-              <a:t>    </a:t>
-            </a:r>
-            <a:r>
-              <a:rPr sz="1700">
-                <a:solidFill>
-                  <a:srgbClr val="CF8E6D"/>
-                </a:solidFill>
-                <a:latin typeface="Consolas"/>
-              </a:rPr>
-              <a:t>public</a:t>
-            </a:r>
-            <a:r>
-              <a:rPr sz="1700">
-                <a:solidFill>
-                  <a:srgbClr val="BCBEC4"/>
-                </a:solidFill>
-                <a:latin typeface="Consolas"/>
-              </a:rPr>
-              <a:t> </a:t>
-            </a:r>
-            <a:r>
-              <a:rPr sz="1700">
-                <a:solidFill>
-                  <a:srgbClr val="CF8E6D"/>
-                </a:solidFill>
-                <a:latin typeface="Consolas"/>
-              </a:rPr>
-              <a:t>boolean</a:t>
-            </a:r>
-            <a:r>
-              <a:rPr sz="1700">
-                <a:solidFill>
-                  <a:srgbClr val="BCBEC4"/>
-                </a:solidFill>
-                <a:latin typeface="Consolas"/>
-              </a:rPr>
-              <a:t> </a:t>
-            </a:r>
-            <a:r>
-              <a:rPr sz="1700">
-                <a:solidFill>
-                  <a:srgbClr val="56A8F5"/>
-                </a:solidFill>
-                <a:latin typeface="Consolas"/>
-              </a:rPr>
-              <a:t>estAllumee</a:t>
-            </a:r>
-            <a:r>
-              <a:rPr sz="1700">
-                <a:solidFill>
-                  <a:srgbClr val="BCBEC4"/>
-                </a:solidFill>
-                <a:latin typeface="Consolas"/>
-              </a:rPr>
-              <a:t>() { </a:t>
-            </a:r>
-            <a:r>
-              <a:rPr sz="1700">
-                <a:solidFill>
-                  <a:srgbClr val="CF8E6D"/>
-                </a:solidFill>
-                <a:latin typeface="Consolas"/>
-              </a:rPr>
-              <a:t>return</a:t>
-            </a:r>
-            <a:r>
-              <a:rPr sz="1700">
-                <a:solidFill>
-                  <a:srgbClr val="BCBEC4"/>
-                </a:solidFill>
-                <a:latin typeface="Consolas"/>
-              </a:rPr>
-              <a:t> allumee; }</a:t>
-            </a:r>
-          </a:p>
-          <a:p>
-            <a:pPr>
-              <a:lnSpc>
-                <a:spcPct val="100000"/>
-              </a:lnSpc>
-              <a:spcBef>
-                <a:spcPts val="0"/>
-              </a:spcBef>
-              <a:spcAft>
-                <a:spcPts val="0"/>
-              </a:spcAft>
-            </a:pPr>
-            <a:r>
-              <a:rPr sz="1700">
-                <a:solidFill>
-                  <a:srgbClr val="BCBEC4"/>
-                </a:solidFill>
-                <a:latin typeface="Consolas"/>
-              </a:rPr>
-              <a:t>}</a:t>
-            </a:r>
-          </a:p>
-          <a:p>
-            <a:pPr>
-              <a:lnSpc>
-                <a:spcPct val="100000"/>
-              </a:lnSpc>
-              <a:spcBef>
-                <a:spcPts val="0"/>
-              </a:spcBef>
-              <a:spcAft>
-                <a:spcPts val="0"/>
-              </a:spcAft>
-            </a:pPr>
-            <a:r>
-              <a:rPr sz="1700">
-                <a:solidFill>
-                  <a:srgbClr val="BCBEC4"/>
-                </a:solidFill>
-                <a:latin typeface="Consolas"/>
-              </a:rPr>
-              <a:t> </a:t>
-            </a:r>
-          </a:p>
-          <a:p>
-            <a:pPr>
-              <a:lnSpc>
-                <a:spcPct val="100000"/>
-              </a:lnSpc>
-              <a:spcBef>
-                <a:spcPts val="0"/>
-              </a:spcBef>
-              <a:spcAft>
-                <a:spcPts val="0"/>
-              </a:spcAft>
-            </a:pPr>
-            <a:r>
-              <a:rPr sz="1700">
-                <a:solidFill>
-                  <a:srgbClr val="CF8E6D"/>
-                </a:solidFill>
-                <a:latin typeface="Consolas"/>
-              </a:rPr>
-              <a:t>private</a:t>
-            </a:r>
-            <a:r>
-              <a:rPr sz="1700">
-                <a:solidFill>
-                  <a:srgbClr val="BCBEC4"/>
-                </a:solidFill>
-                <a:latin typeface="Consolas"/>
-              </a:rPr>
-              <a:t> </a:t>
-            </a:r>
-            <a:r>
-              <a:rPr sz="1700">
-                <a:solidFill>
-                  <a:srgbClr val="CF8E6D"/>
-                </a:solidFill>
-                <a:latin typeface="Consolas"/>
-              </a:rPr>
-              <a:t>void</a:t>
-            </a:r>
-            <a:r>
-              <a:rPr sz="1700">
-                <a:solidFill>
-                  <a:srgbClr val="BCBEC4"/>
-                </a:solidFill>
-                <a:latin typeface="Consolas"/>
-              </a:rPr>
-              <a:t> </a:t>
-            </a:r>
-            <a:r>
-              <a:rPr sz="1700">
-                <a:solidFill>
-                  <a:srgbClr val="56A8F5"/>
-                </a:solidFill>
-                <a:latin typeface="Consolas"/>
-              </a:rPr>
-              <a:t>basculer</a:t>
-            </a:r>
-            <a:r>
-              <a:rPr sz="1700">
-                <a:solidFill>
-                  <a:srgbClr val="BCBEC4"/>
-                </a:solidFill>
-                <a:latin typeface="Consolas"/>
-              </a:rPr>
-              <a:t>() {            </a:t>
-            </a:r>
-            <a:r>
-              <a:rPr sz="1700">
-                <a:solidFill>
-                  <a:srgbClr val="7A7E85"/>
-                </a:solidFill>
-                <a:latin typeface="Consolas"/>
-              </a:rPr>
-              <a:t>// dans le controleur</a:t>
-            </a:r>
-          </a:p>
-          <a:p>
-            <a:pPr>
-              <a:lnSpc>
-                <a:spcPct val="100000"/>
-              </a:lnSpc>
-              <a:spcBef>
-                <a:spcPts val="0"/>
-              </a:spcBef>
-              <a:spcAft>
-                <a:spcPts val="0"/>
-              </a:spcAft>
-            </a:pPr>
-            <a:r>
-              <a:rPr sz="1700">
-                <a:solidFill>
-                  <a:srgbClr val="BCBEC4"/>
-                </a:solidFill>
-                <a:latin typeface="Consolas"/>
-              </a:rPr>
-              <a:t>    lampe.</a:t>
-            </a:r>
-            <a:r>
-              <a:rPr sz="1700">
-                <a:solidFill>
-                  <a:srgbClr val="56A8F5"/>
-                </a:solidFill>
-                <a:latin typeface="Consolas"/>
-              </a:rPr>
-              <a:t>basculer</a:t>
-            </a:r>
-            <a:r>
-              <a:rPr sz="1700">
-                <a:solidFill>
-                  <a:srgbClr val="BCBEC4"/>
-                </a:solidFill>
-                <a:latin typeface="Consolas"/>
-              </a:rPr>
-              <a:t>();</a:t>
-            </a:r>
-          </a:p>
-          <a:p>
-            <a:pPr>
-              <a:lnSpc>
-                <a:spcPct val="100000"/>
-              </a:lnSpc>
-              <a:spcBef>
-                <a:spcPts val="0"/>
-              </a:spcBef>
-              <a:spcAft>
-                <a:spcPts val="0"/>
-              </a:spcAft>
-            </a:pPr>
-            <a:r>
-              <a:rPr sz="1700">
-                <a:solidFill>
-                  <a:srgbClr val="BCBEC4"/>
-                </a:solidFill>
-                <a:latin typeface="Consolas"/>
-              </a:rPr>
-              <a:t>    etat.</a:t>
-            </a:r>
-            <a:r>
-              <a:rPr sz="1700">
-                <a:solidFill>
-                  <a:srgbClr val="56A8F5"/>
-                </a:solidFill>
-                <a:latin typeface="Consolas"/>
-              </a:rPr>
-              <a:t>setText</a:t>
-            </a:r>
-            <a:r>
-              <a:rPr sz="1700">
-                <a:solidFill>
-                  <a:srgbClr val="BCBEC4"/>
-                </a:solidFill>
-                <a:latin typeface="Consolas"/>
-              </a:rPr>
-              <a:t>(lampe.</a:t>
-            </a:r>
-            <a:r>
-              <a:rPr sz="1700">
-                <a:solidFill>
-                  <a:srgbClr val="56A8F5"/>
-                </a:solidFill>
-                <a:latin typeface="Consolas"/>
-              </a:rPr>
-              <a:t>estAllumee</a:t>
-            </a:r>
-            <a:r>
-              <a:rPr sz="1700">
-                <a:solidFill>
-                  <a:srgbClr val="BCBEC4"/>
-                </a:solidFill>
-                <a:latin typeface="Consolas"/>
-              </a:rPr>
-              <a:t>() ? </a:t>
-            </a:r>
-            <a:r>
-              <a:rPr sz="1700">
-                <a:solidFill>
-                  <a:srgbClr val="6AAB73"/>
-                </a:solidFill>
-                <a:latin typeface="Consolas"/>
-              </a:rPr>
-              <a:t>"Allumee"</a:t>
-            </a:r>
-            <a:r>
-              <a:rPr sz="1700">
-                <a:solidFill>
-                  <a:srgbClr val="BCBEC4"/>
-                </a:solidFill>
-                <a:latin typeface="Consolas"/>
-              </a:rPr>
-              <a:t> : </a:t>
-            </a:r>
-            <a:r>
-              <a:rPr sz="1700">
-                <a:solidFill>
-                  <a:srgbClr val="6AAB73"/>
-                </a:solidFill>
-                <a:latin typeface="Consolas"/>
-              </a:rPr>
-              <a:t>"Eteinte"</a:t>
-            </a:r>
-            <a:r>
-              <a:rPr sz="1700">
-                <a:solidFill>
-                  <a:srgbClr val="BCBEC4"/>
-                </a:solidFill>
-                <a:latin typeface="Consolas"/>
-              </a:rPr>
-              <a:t>);</a:t>
-            </a:r>
-          </a:p>
-          <a:p>
-            <a:pPr>
-              <a:lnSpc>
-                <a:spcPct val="100000"/>
-              </a:lnSpc>
-              <a:spcBef>
-                <a:spcPts val="0"/>
-              </a:spcBef>
-              <a:spcAft>
-                <a:spcPts val="0"/>
-              </a:spcAft>
-            </a:pPr>
-            <a:r>
-              <a:rPr sz="1700">
+              <a:rPr sz="1700" dirty="0">
                 <a:solidFill>
                   <a:srgbClr val="BCBEC4"/>
                 </a:solidFill>
@@ -12064,6 +11842,442 @@
                 </a:solidFill>
               </a:rPr>
               <a:t>3. MVC</a:t>
+            </a:r>
+          </a:p>
+        </p:txBody>
+      </p:sp>
+      <p:sp>
+        <p:nvSpPr>
+          <p:cNvPr id="7" name="Code">
+            <a:extLst>
+              <a:ext uri="{FF2B5EF4-FFF2-40B4-BE49-F238E27FC236}">
+                <a16:creationId xmlns:a16="http://schemas.microsoft.com/office/drawing/2014/main" id="{E6EE1B31-0EE8-F295-8BCE-3A800985F7AE}"/>
+              </a:ext>
+            </a:extLst>
+          </p:cNvPr>
+          <p:cNvSpPr txBox="1"/>
+          <p:nvPr/>
+        </p:nvSpPr>
+        <p:spPr>
+          <a:xfrm>
+            <a:off x="1853494" y="3170446"/>
+            <a:ext cx="8485011" cy="1496147"/>
+          </a:xfrm>
+          <a:prstGeom prst="roundRect">
+            <a:avLst>
+              <a:gd name="adj" fmla="val 3191"/>
+            </a:avLst>
+          </a:prstGeom>
+          <a:solidFill>
+            <a:srgbClr val="1D1F22"/>
+          </a:solidFill>
+          <a:effectLst>
+            <a:outerShdw blurRad="50800" dist="38100" dir="2700000" algn="tl" rotWithShape="0">
+              <a:prstClr val="black">
+                <a:alpha val="40000"/>
+              </a:prstClr>
+            </a:outerShdw>
+          </a:effectLst>
+        </p:spPr>
+        <p:txBody>
+          <a:bodyPr wrap="none" lIns="137160" tIns="91440" rIns="137160" bIns="91440"/>
+          <a:lstStyle/>
+          <a:p>
+            <a:pPr>
+              <a:lnSpc>
+                <a:spcPct val="100000"/>
+              </a:lnSpc>
+              <a:spcBef>
+                <a:spcPts val="0"/>
+              </a:spcBef>
+              <a:spcAft>
+                <a:spcPts val="0"/>
+              </a:spcAft>
+            </a:pPr>
+            <a:r>
+              <a:rPr sz="1700" dirty="0">
+                <a:solidFill>
+                  <a:srgbClr val="CF8E6D"/>
+                </a:solidFill>
+                <a:latin typeface="Consolas"/>
+              </a:rPr>
+              <a:t>public</a:t>
+            </a:r>
+            <a:r>
+              <a:rPr sz="1700" dirty="0">
+                <a:solidFill>
+                  <a:srgbClr val="BCBEC4"/>
+                </a:solidFill>
+                <a:latin typeface="Consolas"/>
+              </a:rPr>
+              <a:t> </a:t>
+            </a:r>
+            <a:r>
+              <a:rPr sz="1700" dirty="0">
+                <a:solidFill>
+                  <a:srgbClr val="CF8E6D"/>
+                </a:solidFill>
+                <a:latin typeface="Consolas"/>
+              </a:rPr>
+              <a:t>class</a:t>
+            </a:r>
+            <a:r>
+              <a:rPr sz="1700" dirty="0">
+                <a:solidFill>
+                  <a:srgbClr val="BCBEC4"/>
+                </a:solidFill>
+                <a:latin typeface="Consolas"/>
+              </a:rPr>
+              <a:t> Lampe {                 </a:t>
+            </a:r>
+            <a:r>
+              <a:rPr sz="1700" dirty="0">
+                <a:solidFill>
+                  <a:srgbClr val="7A7E85"/>
+                </a:solidFill>
+                <a:latin typeface="Consolas"/>
+              </a:rPr>
+              <a:t>// le </a:t>
+            </a:r>
+            <a:r>
+              <a:rPr sz="1700" dirty="0" err="1">
+                <a:solidFill>
+                  <a:srgbClr val="7A7E85"/>
+                </a:solidFill>
+                <a:latin typeface="Consolas"/>
+              </a:rPr>
+              <a:t>modele</a:t>
+            </a:r>
+            <a:r>
+              <a:rPr sz="1700" dirty="0">
+                <a:solidFill>
+                  <a:srgbClr val="7A7E85"/>
+                </a:solidFill>
+                <a:latin typeface="Consolas"/>
+              </a:rPr>
+              <a:t>, sans JavaFX</a:t>
+            </a:r>
+          </a:p>
+          <a:p>
+            <a:pPr>
+              <a:lnSpc>
+                <a:spcPct val="100000"/>
+              </a:lnSpc>
+              <a:spcBef>
+                <a:spcPts val="0"/>
+              </a:spcBef>
+              <a:spcAft>
+                <a:spcPts val="0"/>
+              </a:spcAft>
+            </a:pPr>
+            <a:r>
+              <a:rPr sz="1700" dirty="0">
+                <a:solidFill>
+                  <a:srgbClr val="BCBEC4"/>
+                </a:solidFill>
+                <a:latin typeface="Consolas"/>
+              </a:rPr>
+              <a:t>    </a:t>
+            </a:r>
+            <a:r>
+              <a:rPr sz="1700" dirty="0">
+                <a:solidFill>
+                  <a:srgbClr val="CF8E6D"/>
+                </a:solidFill>
+                <a:latin typeface="Consolas"/>
+              </a:rPr>
+              <a:t>private</a:t>
+            </a:r>
+            <a:r>
+              <a:rPr sz="1700" dirty="0">
+                <a:solidFill>
+                  <a:srgbClr val="BCBEC4"/>
+                </a:solidFill>
+                <a:latin typeface="Consolas"/>
+              </a:rPr>
+              <a:t> </a:t>
+            </a:r>
+            <a:r>
+              <a:rPr sz="1700" dirty="0" err="1">
+                <a:solidFill>
+                  <a:srgbClr val="CF8E6D"/>
+                </a:solidFill>
+                <a:latin typeface="Consolas"/>
+              </a:rPr>
+              <a:t>boolean</a:t>
+            </a:r>
+            <a:r>
+              <a:rPr sz="1700" dirty="0">
+                <a:solidFill>
+                  <a:srgbClr val="BCBEC4"/>
+                </a:solidFill>
+                <a:latin typeface="Consolas"/>
+              </a:rPr>
+              <a:t> </a:t>
+            </a:r>
+            <a:r>
+              <a:rPr sz="1700" dirty="0" err="1">
+                <a:solidFill>
+                  <a:srgbClr val="BCBEC4"/>
+                </a:solidFill>
+                <a:latin typeface="Consolas"/>
+              </a:rPr>
+              <a:t>allumee</a:t>
+            </a:r>
+            <a:r>
+              <a:rPr sz="1700" dirty="0">
+                <a:solidFill>
+                  <a:srgbClr val="BCBEC4"/>
+                </a:solidFill>
+                <a:latin typeface="Consolas"/>
+              </a:rPr>
+              <a:t>;</a:t>
+            </a:r>
+          </a:p>
+          <a:p>
+            <a:pPr>
+              <a:lnSpc>
+                <a:spcPct val="100000"/>
+              </a:lnSpc>
+              <a:spcBef>
+                <a:spcPts val="0"/>
+              </a:spcBef>
+              <a:spcAft>
+                <a:spcPts val="0"/>
+              </a:spcAft>
+            </a:pPr>
+            <a:r>
+              <a:rPr sz="1700" dirty="0">
+                <a:solidFill>
+                  <a:srgbClr val="BCBEC4"/>
+                </a:solidFill>
+                <a:latin typeface="Consolas"/>
+              </a:rPr>
+              <a:t>    </a:t>
+            </a:r>
+            <a:r>
+              <a:rPr sz="1700" dirty="0">
+                <a:solidFill>
+                  <a:srgbClr val="CF8E6D"/>
+                </a:solidFill>
+                <a:latin typeface="Consolas"/>
+              </a:rPr>
+              <a:t>public</a:t>
+            </a:r>
+            <a:r>
+              <a:rPr sz="1700" dirty="0">
+                <a:solidFill>
+                  <a:srgbClr val="BCBEC4"/>
+                </a:solidFill>
+                <a:latin typeface="Consolas"/>
+              </a:rPr>
+              <a:t> </a:t>
+            </a:r>
+            <a:r>
+              <a:rPr sz="1700" dirty="0">
+                <a:solidFill>
+                  <a:srgbClr val="CF8E6D"/>
+                </a:solidFill>
+                <a:latin typeface="Consolas"/>
+              </a:rPr>
+              <a:t>void</a:t>
+            </a:r>
+            <a:r>
+              <a:rPr sz="1700" dirty="0">
+                <a:solidFill>
+                  <a:srgbClr val="BCBEC4"/>
+                </a:solidFill>
+                <a:latin typeface="Consolas"/>
+              </a:rPr>
+              <a:t> </a:t>
+            </a:r>
+            <a:r>
+              <a:rPr sz="1700" dirty="0" err="1">
+                <a:solidFill>
+                  <a:srgbClr val="56A8F5"/>
+                </a:solidFill>
+                <a:latin typeface="Consolas"/>
+              </a:rPr>
+              <a:t>basculer</a:t>
+            </a:r>
+            <a:r>
+              <a:rPr sz="1700" dirty="0">
+                <a:solidFill>
+                  <a:srgbClr val="BCBEC4"/>
+                </a:solidFill>
+                <a:latin typeface="Consolas"/>
+              </a:rPr>
+              <a:t>() { </a:t>
+            </a:r>
+            <a:r>
+              <a:rPr sz="1700" dirty="0" err="1">
+                <a:solidFill>
+                  <a:srgbClr val="BCBEC4"/>
+                </a:solidFill>
+                <a:latin typeface="Consolas"/>
+              </a:rPr>
+              <a:t>allumee</a:t>
+            </a:r>
+            <a:r>
+              <a:rPr sz="1700" dirty="0">
+                <a:solidFill>
+                  <a:srgbClr val="BCBEC4"/>
+                </a:solidFill>
+                <a:latin typeface="Consolas"/>
+              </a:rPr>
+              <a:t> = !</a:t>
+            </a:r>
+            <a:r>
+              <a:rPr sz="1700" dirty="0" err="1">
+                <a:solidFill>
+                  <a:srgbClr val="BCBEC4"/>
+                </a:solidFill>
+                <a:latin typeface="Consolas"/>
+              </a:rPr>
+              <a:t>allumee</a:t>
+            </a:r>
+            <a:r>
+              <a:rPr sz="1700" dirty="0">
+                <a:solidFill>
+                  <a:srgbClr val="BCBEC4"/>
+                </a:solidFill>
+                <a:latin typeface="Consolas"/>
+              </a:rPr>
+              <a:t>; }</a:t>
+            </a:r>
+          </a:p>
+          <a:p>
+            <a:pPr>
+              <a:lnSpc>
+                <a:spcPct val="100000"/>
+              </a:lnSpc>
+              <a:spcBef>
+                <a:spcPts val="0"/>
+              </a:spcBef>
+              <a:spcAft>
+                <a:spcPts val="0"/>
+              </a:spcAft>
+            </a:pPr>
+            <a:r>
+              <a:rPr sz="1700" dirty="0">
+                <a:solidFill>
+                  <a:srgbClr val="BCBEC4"/>
+                </a:solidFill>
+                <a:latin typeface="Consolas"/>
+              </a:rPr>
+              <a:t>    </a:t>
+            </a:r>
+            <a:r>
+              <a:rPr sz="1700" dirty="0">
+                <a:solidFill>
+                  <a:srgbClr val="CF8E6D"/>
+                </a:solidFill>
+                <a:latin typeface="Consolas"/>
+              </a:rPr>
+              <a:t>public</a:t>
+            </a:r>
+            <a:r>
+              <a:rPr sz="1700" dirty="0">
+                <a:solidFill>
+                  <a:srgbClr val="BCBEC4"/>
+                </a:solidFill>
+                <a:latin typeface="Consolas"/>
+              </a:rPr>
+              <a:t> </a:t>
+            </a:r>
+            <a:r>
+              <a:rPr sz="1700" dirty="0" err="1">
+                <a:solidFill>
+                  <a:srgbClr val="CF8E6D"/>
+                </a:solidFill>
+                <a:latin typeface="Consolas"/>
+              </a:rPr>
+              <a:t>boolean</a:t>
+            </a:r>
+            <a:r>
+              <a:rPr sz="1700" dirty="0">
+                <a:solidFill>
+                  <a:srgbClr val="BCBEC4"/>
+                </a:solidFill>
+                <a:latin typeface="Consolas"/>
+              </a:rPr>
+              <a:t> </a:t>
+            </a:r>
+            <a:r>
+              <a:rPr sz="1700" dirty="0" err="1">
+                <a:solidFill>
+                  <a:srgbClr val="56A8F5"/>
+                </a:solidFill>
+                <a:latin typeface="Consolas"/>
+              </a:rPr>
+              <a:t>estAllumee</a:t>
+            </a:r>
+            <a:r>
+              <a:rPr sz="1700" dirty="0">
+                <a:solidFill>
+                  <a:srgbClr val="BCBEC4"/>
+                </a:solidFill>
+                <a:latin typeface="Consolas"/>
+              </a:rPr>
+              <a:t>() { </a:t>
+            </a:r>
+            <a:r>
+              <a:rPr sz="1700" dirty="0">
+                <a:solidFill>
+                  <a:srgbClr val="CF8E6D"/>
+                </a:solidFill>
+                <a:latin typeface="Consolas"/>
+              </a:rPr>
+              <a:t>return</a:t>
+            </a:r>
+            <a:r>
+              <a:rPr sz="1700" dirty="0">
+                <a:solidFill>
+                  <a:srgbClr val="BCBEC4"/>
+                </a:solidFill>
+                <a:latin typeface="Consolas"/>
+              </a:rPr>
+              <a:t> </a:t>
+            </a:r>
+            <a:r>
+              <a:rPr sz="1700" dirty="0" err="1">
+                <a:solidFill>
+                  <a:srgbClr val="BCBEC4"/>
+                </a:solidFill>
+                <a:latin typeface="Consolas"/>
+              </a:rPr>
+              <a:t>allumee</a:t>
+            </a:r>
+            <a:r>
+              <a:rPr sz="1700" dirty="0">
+                <a:solidFill>
+                  <a:srgbClr val="BCBEC4"/>
+                </a:solidFill>
+                <a:latin typeface="Consolas"/>
+              </a:rPr>
+              <a:t>; }</a:t>
+            </a:r>
+          </a:p>
+          <a:p>
+            <a:pPr>
+              <a:lnSpc>
+                <a:spcPct val="100000"/>
+              </a:lnSpc>
+              <a:spcBef>
+                <a:spcPts val="0"/>
+              </a:spcBef>
+              <a:spcAft>
+                <a:spcPts val="0"/>
+              </a:spcAft>
+            </a:pPr>
+            <a:r>
+              <a:rPr sz="1700" dirty="0">
+                <a:solidFill>
+                  <a:srgbClr val="BCBEC4"/>
+                </a:solidFill>
+                <a:latin typeface="Consolas"/>
+              </a:rPr>
+              <a:t>}</a:t>
             </a:r>
           </a:p>
         </p:txBody>
@@ -12134,6 +12348,59 @@
                       </p:childTnLst>
                     </p:cTn>
                   </p:par>
+                  <p:par>
+                    <p:cTn id="8" fill="hold">
+                      <p:stCondLst>
+                        <p:cond delay="indefinite"/>
+                      </p:stCondLst>
+                      <p:childTnLst>
+                        <p:par>
+                          <p:cTn id="9" fill="hold">
+                            <p:stCondLst>
+                              <p:cond delay="0"/>
+                            </p:stCondLst>
+                            <p:childTnLst>
+                              <p:par>
+                                <p:cTn id="10" presetID="10" presetClass="entr" presetSubtype="0" fill="hold" grpId="0" nodeType="clickEffect">
+                                  <p:stCondLst>
+                                    <p:cond delay="0"/>
+                                  </p:stCondLst>
+                                  <p:childTnLst>
+                                    <p:set>
+                                      <p:cBhvr>
+                                        <p:cTn id="11" dur="1" fill="hold">
+                                          <p:stCondLst>
+                                            <p:cond delay="0"/>
+                                          </p:stCondLst>
+                                        </p:cTn>
+                                        <p:tgtEl>
+                                          <p:spTgt spid="7"/>
+                                        </p:tgtEl>
+                                        <p:attrNameLst>
+                                          <p:attrName>style.visibility</p:attrName>
+                                        </p:attrNameLst>
+                                      </p:cBhvr>
+                                      <p:to>
+                                        <p:strVal val="visible"/>
+                                      </p:to>
+                                    </p:set>
+                                    <p:animEffect transition="in" filter="fade">
+                                      <p:cBhvr>
+                                        <p:cTn id="12" dur="500"/>
+                                        <p:tgtEl>
+                                          <p:spTgt spid="7"/>
+                                        </p:tgtEl>
+                                      </p:cBhvr>
+                                    </p:animEffect>
+                                  </p:childTnLst>
+                                </p:cTn>
+                              </p:par>
+                            </p:childTnLst>
+                          </p:cTn>
+                        </p:par>
+                      </p:childTnLst>
+                    </p:cTn>
+                  </p:par>
                 </p:childTnLst>
               </p:cTn>
               <p:prevCondLst>
@@ -12157,6 +12424,7 @@
     </p:tnLst>
     <p:bldLst>
       <p:bldP spid="4" grpId="0" animBg="1"/>
+      <p:bldP spid="7" grpId="0" animBg="1"/>
     </p:bldLst>
   </p:timing>
 </p:sld>
@@ -13221,11 +13489,11 @@
             </a:r>
             <a:r>
               <a:rPr lang="fr-FR" dirty="0" err="1"/>
-              <a:t>fxml</a:t>
+              <a:t>FXML</a:t>
             </a:r>
             <a:r>
               <a:rPr lang="fr-FR" dirty="0"/>
-              <a:t>, une spécialisation de xml…</a:t>
+              <a:t>, une spécialisation de XML…</a:t>
             </a:r>
           </a:p>
         </p:txBody>

</xml_diff>